<commit_message>
Sync slide numbers with report after leakage-fix retrain
Updated stat tiles (84.3%/11.3%), threshold-tuning numbers (0.844 ->
28.9%/37.0%/0.324), and the "đã khắc phục" slide to cover both bugs
(xmin/xmax + global-stats leakage) instead of just the first one —
now matches BaoCao_TongHop_RBA.docx.
</commit_message>
<xml_diff>
--- a/SlideThuyetTrinh_RBA_MLP_Fuzzy.pptx
+++ b/SlideThuyetTrinh_RBA_MLP_Fuzzy.pptx
@@ -6303,7 +6303,7 @@
                 <a:ea typeface="Cambria" pitchFamily="34" charset="-122"/>
                 <a:cs typeface="Cambria" pitchFamily="34" charset="-120"/>
               </a:rPr>
-              <a:t>87.7%</a:t>
+              <a:t>87.8%</a:t>
             </a:r>
             <a:endParaRPr lang="en-US" sz="2700" dirty="0"/>
           </a:p>
@@ -6408,7 +6408,7 @@
                 <a:ea typeface="Cambria" pitchFamily="34" charset="-122"/>
                 <a:cs typeface="Cambria" pitchFamily="34" charset="-120"/>
               </a:rPr>
-              <a:t>21.9%</a:t>
+              <a:t>21.8%</a:t>
             </a:r>
             <a:endParaRPr lang="en-US" sz="2700" dirty="0"/>
           </a:p>
@@ -6513,7 +6513,7 @@
                 <a:ea typeface="Cambria" pitchFamily="34" charset="-122"/>
                 <a:cs typeface="Cambria" pitchFamily="34" charset="-120"/>
               </a:rPr>
-              <a:t>79.0%</a:t>
+              <a:t>79.3%</a:t>
             </a:r>
             <a:endParaRPr lang="en-US" sz="2700" dirty="0"/>
           </a:p>
@@ -6618,7 +6618,7 @@
                 <a:ea typeface="Cambria" pitchFamily="34" charset="-122"/>
                 <a:cs typeface="Cambria" pitchFamily="34" charset="-120"/>
               </a:rPr>
-              <a:t>11.2%</a:t>
+              <a:t>11.3%</a:t>
             </a:r>
             <a:endParaRPr lang="en-US" sz="2700" dirty="0"/>
           </a:p>
@@ -6723,7 +6723,7 @@
                 <a:ea typeface="Cambria" pitchFamily="34" charset="-122"/>
                 <a:cs typeface="Cambria" pitchFamily="34" charset="-120"/>
               </a:rPr>
-              <a:t>84.5%</a:t>
+              <a:t>84.3%</a:t>
             </a:r>
             <a:endParaRPr lang="en-US" sz="2700" dirty="0"/>
           </a:p>
@@ -6828,7 +6828,7 @@
                 <a:ea typeface="Cambria" pitchFamily="34" charset="-122"/>
                 <a:cs typeface="Cambria" pitchFamily="34" charset="-120"/>
               </a:rPr>
-              <a:t>19.7%</a:t>
+              <a:t>20.0%</a:t>
             </a:r>
             <a:endParaRPr lang="en-US" sz="2700" dirty="0"/>
           </a:p>
@@ -6909,7 +6909,7 @@
                 <a:ea typeface="Calibri" pitchFamily="34" charset="-122"/>
                 <a:cs typeface="Calibri" pitchFamily="34" charset="-120"/>
               </a:rPr>
-              <a:t>Recall cao (84.5%) — bắt được phần lớn tấn công thật.  Precision thấp (11.2%) — hệ quả của dữ liệu mất cân bằng (~3% dương) ở ngưỡng mặc định 0.5. Đổi ngưỡng theo F1 (0.829): Precision → 27.8%, F1 → 0.327.</a:t>
+              <a:t>Recall cao (84.3%) — bắt được phần lớn tấn công thật.  Precision thấp (11.3%) — hệ quả của dữ liệu mất cân bằng (~3% dương) ở ngưỡng mặc định 0.5. Đổi ngưỡng theo F1 (0.844): Precision → 28.9%, F1 → 0.324.</a:t>
             </a:r>
             <a:endParaRPr lang="en-US" sz="1400" dirty="0"/>
           </a:p>
@@ -7214,7 +7214,7 @@
                 <a:ea typeface="Calibri" pitchFamily="34" charset="-122"/>
                 <a:cs typeface="Calibri" pitchFamily="34" charset="-120"/>
               </a:rPr>
-              <a:t>Train loss giảm ổn định, Val AUPRC/AUROC hội tụ trước epoch 30 (early stopping kích hoạt) → mô hình không overfitting. AUC-ROC = 0.877 cho thấy khả năng phân biệt tốt; đường Precision-Recall thấp hơn nhiều so với ROC — đúng đặc trưng của bài toán có tỷ lệ dương chỉ ~3%, nơi AUPRC phản ánh độ khó thực tế rõ hơn AUROC.</a:t>
+              <a:t>Train loss giảm ổn định, Val AUPRC/AUROC hội tụ trước epoch 30 (early stopping kích hoạt) → mô hình không overfitting. AUC-ROC = 0.878 cho thấy khả năng phân biệt tốt; đường Precision-Recall thấp hơn nhiều so với ROC — đúng đặc trưng của bài toán có tỷ lệ dương chỉ ~3%, nơi AUPRC phản ánh độ khó thực tế rõ hơn AUROC.</a:t>
             </a:r>
             <a:endParaRPr lang="en-US" sz="1400" dirty="0"/>
           </a:p>
@@ -7397,7 +7397,7 @@
         </p:nvSpPr>
         <p:spPr>
           <a:xfrm>
-            <a:off x="822960" y="2011680"/>
+            <a:off x="822960" y="1965960"/>
             <a:ext cx="4846320" cy="457200"/>
           </a:xfrm>
           <a:prstGeom prst="rect">
@@ -7414,7 +7414,7 @@
               <a:buNone/>
             </a:pPr>
             <a:r>
-              <a:rPr lang="en-US" sz="1550" b="1" dirty="0">
+              <a:rPr lang="en-US" sz="1450" b="1" dirty="0">
                 <a:solidFill>
                   <a:srgbClr val="0CA30C"/>
                 </a:solidFill>
@@ -7422,9 +7422,9 @@
                 <a:ea typeface="Cambria" pitchFamily="34" charset="-122"/>
                 <a:cs typeface="Cambria" pitchFamily="34" charset="-120"/>
               </a:rPr>
-              <a:t>✓  ĐÃ PHÁT HIỆN &amp; KHẮC PHỤC</a:t>
-            </a:r>
-            <a:endParaRPr lang="en-US" sz="1550" dirty="0"/>
+              <a:t>✓  ĐÃ PHÁT HIỆN &amp; KHẮC PHỤC (2 lỗi)</a:t>
+            </a:r>
+            <a:endParaRPr lang="en-US" sz="1450" dirty="0"/>
           </a:p>
         </p:txBody>
       </p:sp>
@@ -7436,8 +7436,8 @@
         </p:nvSpPr>
         <p:spPr>
           <a:xfrm>
-            <a:off x="822960" y="2560320"/>
-            <a:ext cx="4846320" cy="3383280"/>
+            <a:off x="822960" y="2468880"/>
+            <a:ext cx="4846320" cy="3474720"/>
           </a:xfrm>
           <a:prstGeom prst="rect">
             <a:avLst/>
@@ -7451,16 +7451,16 @@
           <a:p>
             <a:pPr marL="342900" indent="-342900">
               <a:lnSpc>
-                <a:spcPts val="1800"/>
+                <a:spcPts val="1600"/>
               </a:lnSpc>
               <a:spcAft>
-                <a:spcPts val="1000"/>
+                <a:spcPts val="800"/>
               </a:spcAft>
               <a:buSzPct val="100000"/>
               <a:buChar char="•"/>
             </a:pPr>
             <a:r>
-              <a:rPr lang="en-US" sz="1300" dirty="0">
+              <a:rPr lang="en-US" sz="1200" dirty="0">
                 <a:solidFill>
                   <a:srgbClr val="232323"/>
                 </a:solidFill>
@@ -7468,23 +7468,23 @@
                 <a:ea typeface="Calibri" pitchFamily="34" charset="-122"/>
                 <a:cs typeface="Calibri" pitchFamily="34" charset="-120"/>
               </a:rPr>
-              <a:t>Hàm xmin/xmax trong fuzzy_mamdani.py từng tính lại theo từng batch — méo kết quả khi suy luận trên 1 dòng đơn lẻ (real-time).</a:t>
-            </a:r>
-            <a:endParaRPr lang="en-US" sz="1300" dirty="0"/>
+              <a:t>xmin/xmax trong fuzzy_mamdani.py từng tính lại theo batch — méo kết quả khi suy luận 1 dòng đơn lẻ. Đã sửa: lưu cố định từ fit().</a:t>
+            </a:r>
+            <a:endParaRPr lang="en-US" sz="1200" dirty="0"/>
           </a:p>
           <a:p>
             <a:pPr marL="342900" indent="-342900">
               <a:lnSpc>
-                <a:spcPts val="1800"/>
+                <a:spcPts val="1600"/>
               </a:lnSpc>
               <a:spcAft>
-                <a:spcPts val="1000"/>
+                <a:spcPts val="800"/>
               </a:spcAft>
               <a:buSzPct val="100000"/>
               <a:buChar char="•"/>
             </a:pPr>
             <a:r>
-              <a:rPr lang="en-US" sz="1300" dirty="0">
+              <a:rPr lang="en-US" sz="1200" dirty="0">
                 <a:solidFill>
                   <a:srgbClr val="232323"/>
                 </a:solidFill>
@@ -7492,20 +7492,20 @@
                 <a:ea typeface="Calibri" pitchFamily="34" charset="-122"/>
                 <a:cs typeface="Calibri" pitchFamily="34" charset="-120"/>
               </a:rPr>
-              <a:t>Đã sửa: lưu xmin/xmax toàn cục từ fit(), dùng cố định trong transform().</a:t>
-            </a:r>
-            <a:endParaRPr lang="en-US" sz="1300" dirty="0"/>
+              <a:t>Leakage thống kê toàn cục: median RTT và độ hiếm Country/ASN trước đây tính trên CẢ dữ liệu (gồm val/test). Đã sửa: fit_global_stats() chỉ trên train.</a:t>
+            </a:r>
+            <a:endParaRPr lang="en-US" sz="1200" dirty="0"/>
           </a:p>
           <a:p>
             <a:pPr marL="342900" indent="-342900">
               <a:lnSpc>
-                <a:spcPts val="1800"/>
+                <a:spcPts val="1600"/>
               </a:lnSpc>
               <a:buSzPct val="100000"/>
               <a:buChar char="•"/>
             </a:pPr>
             <a:r>
-              <a:rPr lang="en-US" sz="1300" dirty="0">
+              <a:rPr lang="en-US" sz="1200" dirty="0">
                 <a:solidFill>
                   <a:srgbClr val="232323"/>
                 </a:solidFill>
@@ -7513,9 +7513,9 @@
                 <a:ea typeface="Calibri" pitchFamily="34" charset="-122"/>
                 <a:cs typeface="Calibri" pitchFamily="34" charset="-120"/>
               </a:rPr>
-              <a:t>Huấn luyện lại — kiểm chứng bằng demo: kịch bản rủi ro cao/thấp cho xác suất 76.9% / 26.3%, tách biệt rõ ràng.</a:t>
-            </a:r>
-            <a:endParaRPr lang="en-US" sz="1300" dirty="0"/>
+              <a:t>Đã huấn luyện lại sau cả 2 lần sửa — kiểm chứng bằng demo inference.py cho kết quả tách biệt hợp lý giữa 2 kịch bản.</a:t>
+            </a:r>
+            <a:endParaRPr lang="en-US" sz="1200" dirty="0"/>
           </a:p>
         </p:txBody>
       </p:sp>
@@ -7625,7 +7625,7 @@
                 <a:ea typeface="Calibri" pitchFamily="34" charset="-122"/>
                 <a:cs typeface="Calibri" pitchFamily="34" charset="-120"/>
               </a:rPr>
-              <a:t>Precision thấp (11.2%) ở ngưỡng 0.5. Đổi ngưỡng F1 (0.829) → Precision 27.8%, nhưng Recall giảm còn 39.8% — vẫn cần đánh đổi theo mục tiêu thực tế.</a:t>
+              <a:t>Precision thấp (11.3%) ở ngưỡng 0.5. Đổi ngưỡng F1 (0.844) → Precision 28.9%, nhưng Recall giảm còn 37.0% — vẫn cần đánh đổi theo mục tiêu thực tế.</a:t>
             </a:r>
             <a:endParaRPr lang="en-US" sz="1250" dirty="0"/>
           </a:p>
@@ -7897,7 +7897,7 @@
                 <a:ea typeface="Calibri" pitchFamily="34" charset="-122"/>
                 <a:cs typeface="Calibri" pitchFamily="34" charset="-120"/>
               </a:rPr>
-              <a:t>Mamdani Fuzzy Inference System mã hoá tri thức chuyên gia (8 luật IF-THEN) thành đặc trưng bổ sung; MLP học phần còn lại từ dữ liệu thô. Trên 500.000 lượt đăng nhập thật, mô hình đạt AUROC 0.877 và Recall 84.5% — phát hiện được phần lớn tấn công, với đánh đổi báo động giả có thể điều chỉnh qua ngưỡng quyết định.</a:t>
+              <a:t>Mamdani Fuzzy Inference System mã hoá tri thức chuyên gia (8 luật IF-THEN) thành đặc trưng bổ sung; MLP học phần còn lại từ dữ liệu thô. Trên 500.000 lượt đăng nhập thật, mô hình đạt AUROC 0.878 và Recall 84.3% — phát hiện được phần lớn tấn công, với đánh đổi báo động giả có thể điều chỉnh qua ngưỡng quyết định.</a:t>
             </a:r>
             <a:endParaRPr lang="en-US" sz="1600" dirty="0"/>
           </a:p>

</xml_diff>

<commit_message>
Add student names/MSSV/class to title pages
Phạm Trung Kiên (2591310), Nguyễn Minh Tuấn (2591325), Lê Phú Nhân
(2591317) — Lớp KHMT 2025B. Added to both BaoCao_TongHop_RBA.docx
(previously had no name field at all) and the pptx title slide.
</commit_message>
<xml_diff>
--- a/SlideThuyetTrinh_RBA_MLP_Fuzzy.pptx
+++ b/SlideThuyetTrinh_RBA_MLP_Fuzzy.pptx
@@ -2657,7 +2657,7 @@
         </p:nvSpPr>
         <p:spPr>
           <a:xfrm>
-            <a:off x="822960" y="5349240"/>
+            <a:off x="822960" y="5212080"/>
             <a:ext cx="2926080" cy="0"/>
           </a:xfrm>
           <a:prstGeom prst="line">
@@ -2680,8 +2680,8 @@
         </p:nvSpPr>
         <p:spPr>
           <a:xfrm>
-            <a:off x="822960" y="5532120"/>
-            <a:ext cx="10058400" cy="457200"/>
+            <a:off x="822960" y="5349240"/>
+            <a:ext cx="10058400" cy="365760"/>
           </a:xfrm>
           <a:prstGeom prst="rect">
             <a:avLst/>
@@ -2705,7 +2705,46 @@
                 <a:ea typeface="Calibri" pitchFamily="34" charset="-122"/>
                 <a:cs typeface="Calibri" pitchFamily="34" charset="-120"/>
               </a:rPr>
-              <a:t>Họ và tên: ..............................       MSSV: ..............................       Lớp: ..............................</a:t>
+              <a:t>Phạm Trung Kiên — 2591310      Nguyễn Minh Tuấn — 2591325      Lê Phú Nhân — 2591317</a:t>
+            </a:r>
+            <a:endParaRPr lang="en-US" sz="1300" dirty="0"/>
+          </a:p>
+        </p:txBody>
+      </p:sp>
+      <p:sp>
+        <p:nvSpPr>
+          <p:cNvPr id="10" name="Text 8"/>
+          <p:cNvSpPr/>
+          <p:nvPr/>
+        </p:nvSpPr>
+        <p:spPr>
+          <a:xfrm>
+            <a:off x="822960" y="5715000"/>
+            <a:ext cx="10058400" cy="365760"/>
+          </a:xfrm>
+          <a:prstGeom prst="rect">
+            <a:avLst/>
+          </a:prstGeom>
+          <a:noFill/>
+          <a:ln/>
+        </p:spPr>
+        <p:txBody>
+          <a:bodyPr wrap="square" rtlCol="0" anchor="ctr"/>
+          <a:lstStyle/>
+          <a:p>
+            <a:pPr indent="0" marL="0">
+              <a:buNone/>
+            </a:pPr>
+            <a:r>
+              <a:rPr lang="en-US" sz="1300" dirty="0">
+                <a:solidFill>
+                  <a:srgbClr val="C3C2B7"/>
+                </a:solidFill>
+                <a:latin typeface="Calibri" pitchFamily="34" charset="0"/>
+                <a:ea typeface="Calibri" pitchFamily="34" charset="-122"/>
+                <a:cs typeface="Calibri" pitchFamily="34" charset="-120"/>
+              </a:rPr>
+              <a:t>Lớp: KHMT 2025B</a:t>
             </a:r>
             <a:endParaRPr lang="en-US" sz="1300" dirty="0"/>
           </a:p>

</xml_diff>